<commit_message>
Add GovEnrich hackathon pitch deck (.pptx + .pdf)
6-slide pitch for Apollo x Google Cloud Hackathon targeting
Best Use of Claude Code. EdgeTrace brand (Poppins, #9C81AA purple,
#0C0C0C dark). Covers problem, solution architecture, Claude Code
agent workflow, live enrichment demo, and roadmap.
</commit_message>
<xml_diff>
--- a/GovEnrich-Pitch.pptx
+++ b/GovEnrich-Pitch.pptx
@@ -3673,7 +3673,7 @@
                 <a:ea typeface="Poppins" pitchFamily="34" charset="-122"/>
                 <a:cs typeface="Poppins" pitchFamily="34" charset="-120"/>
               </a:rPr>
-              <a:t>Claude Code didn't just help write code — it architected the entire plugin.</a:t>
+              <a:t>Three autonomous Claude Code agents wrote, tested, and shipped every line of GovEnrich.</a:t>
             </a:r>
             <a:endParaRPr lang="en-US" sz="1400" dirty="0"/>
           </a:p>
@@ -4394,7 +4394,7 @@
                 <a:ea typeface="Poppins" pitchFamily="34" charset="-122"/>
                 <a:cs typeface="Poppins" pitchFamily="34" charset="-120"/>
               </a:rPr>
-              <a:t>4</a:t>
+              <a:t>3</a:t>
             </a:r>
             <a:endParaRPr lang="en-US" sz="2600" dirty="0"/>
           </a:p>
@@ -4433,7 +4433,7 @@
                 <a:ea typeface="Poppins" pitchFamily="34" charset="-122"/>
                 <a:cs typeface="Poppins" pitchFamily="34" charset="-120"/>
               </a:rPr>
-              <a:t>MCP Tools</a:t>
+              <a:t>Claude Code Agents wrote the code</a:t>
             </a:r>
             <a:endParaRPr lang="en-US" sz="1200" dirty="0"/>
           </a:p>
@@ -4472,7 +4472,7 @@
                 <a:ea typeface="Poppins" pitchFamily="34" charset="-122"/>
                 <a:cs typeface="Poppins" pitchFamily="34" charset="-120"/>
               </a:rPr>
-              <a:t>3</a:t>
+              <a:t>4</a:t>
             </a:r>
             <a:endParaRPr lang="en-US" sz="2600" dirty="0"/>
           </a:p>
@@ -4511,7 +4511,7 @@
                 <a:ea typeface="Poppins" pitchFamily="34" charset="-122"/>
                 <a:cs typeface="Poppins" pitchFamily="34" charset="-120"/>
               </a:rPr>
-              <a:t>Claude Code Agents</a:t>
+              <a:t>MCP Tools shipped</a:t>
             </a:r>
             <a:endParaRPr lang="en-US" sz="1200" dirty="0"/>
           </a:p>
@@ -4589,7 +4589,7 @@
                 <a:ea typeface="Poppins" pitchFamily="34" charset="-122"/>
                 <a:cs typeface="Poppins" pitchFamily="34" charset="-120"/>
               </a:rPr>
-              <a:t>API Endpoints</a:t>
+              <a:t>API Endpoints wired</a:t>
             </a:r>
             <a:endParaRPr lang="en-US" sz="1200" dirty="0"/>
           </a:p>
@@ -4628,7 +4628,7 @@
                 <a:ea typeface="Poppins" pitchFamily="34" charset="-122"/>
                 <a:cs typeface="Poppins" pitchFamily="34" charset="-120"/>
               </a:rPr>
-              <a:t>100%</a:t>
+              <a:t>0</a:t>
             </a:r>
             <a:endParaRPr lang="en-US" sz="2600" dirty="0"/>
           </a:p>
@@ -4667,7 +4667,7 @@
                 <a:ea typeface="Poppins" pitchFamily="34" charset="-122"/>
                 <a:cs typeface="Poppins" pitchFamily="34" charset="-120"/>
               </a:rPr>
-              <a:t>Go — Single Binary</a:t>
+              <a:t>Lines written by hand</a:t>
             </a:r>
             <a:endParaRPr lang="en-US" sz="1200" dirty="0"/>
           </a:p>

</xml_diff>